<commit_message>
Update sample PowerPoint to thumbs up and down
</commit_message>
<xml_diff>
--- a/public/demo/SlideSense-demo.pptx
+++ b/public/demo/SlideSense-demo.pptx
@@ -2,17 +2,17 @@
 <file path=ppt/presentation.xml><?xml version="1.0" encoding="utf-8"?>
 <p:presentation xmlns:p="http://schemas.openxmlformats.org/presentationml/2006/main">
   <p:sldMasterIdLst>
-    <p:sldMasterId xmlns:r="http://schemas.openxmlformats.org/officeDocument/2006/relationships" id="2147483648" r:id="R4d2c2dc5a5d24357"/>
+    <p:sldMasterId xmlns:r="http://schemas.openxmlformats.org/officeDocument/2006/relationships" id="2147483648" r:id="R50050cf151ff4d79"/>
   </p:sldMasterIdLst>
   <p:notesMasterIdLst>
-    <p:notesMasterId xmlns:r="http://schemas.openxmlformats.org/officeDocument/2006/relationships" r:id="R3d59fed64de14402"/>
+    <p:notesMasterId xmlns:r="http://schemas.openxmlformats.org/officeDocument/2006/relationships" r:id="R2cca945cd1bd452f"/>
   </p:notesMasterIdLst>
   <p:sldIdLst>
-    <p:sldId xmlns:r="http://schemas.openxmlformats.org/officeDocument/2006/relationships" id="256" r:id="Rf343715545254812"/>
-    <p:sldId xmlns:r="http://schemas.openxmlformats.org/officeDocument/2006/relationships" id="257" r:id="R3ebbf55fd59c4451"/>
-    <p:sldId xmlns:r="http://schemas.openxmlformats.org/officeDocument/2006/relationships" id="258" r:id="R54244566c2e24fd6"/>
-    <p:sldId xmlns:r="http://schemas.openxmlformats.org/officeDocument/2006/relationships" id="259" r:id="Re3aa6fc1ad2041d4"/>
-    <p:sldId xmlns:r="http://schemas.openxmlformats.org/officeDocument/2006/relationships" id="260" r:id="R7a68ecc448084c5e"/>
+    <p:sldId xmlns:r="http://schemas.openxmlformats.org/officeDocument/2006/relationships" id="256" r:id="R034436d6077d471e"/>
+    <p:sldId xmlns:r="http://schemas.openxmlformats.org/officeDocument/2006/relationships" id="257" r:id="Rbdbf7a4ad3c443bb"/>
+    <p:sldId xmlns:r="http://schemas.openxmlformats.org/officeDocument/2006/relationships" id="258" r:id="R6519032e9690459a"/>
+    <p:sldId xmlns:r="http://schemas.openxmlformats.org/officeDocument/2006/relationships" id="259" r:id="R3fa2f2ec0558455a"/>
+    <p:sldId xmlns:r="http://schemas.openxmlformats.org/officeDocument/2006/relationships" id="260" r:id="R12f23713faf64f74"/>
   </p:sldIdLst>
   <p:sldSz cx="12192000" cy="6858000"/>
   <p:notesSz cx="6858000" cy="9144000"/>
@@ -794,7 +794,7 @@
   </p:cSld>
   <p:clrMap bg1="lt1" tx1="dk1" bg2="lt2" tx2="dk2" accent1="accent1" accent2="accent2" accent3="accent3" accent4="accent4" accent5="accent5" accent6="accent6" hlink="hlink" folHlink="folHlink"/>
   <p:sldLayoutIdLst>
-    <p:sldLayoutId xmlns:r="http://schemas.openxmlformats.org/officeDocument/2006/relationships" id="2147483649" r:id="Rfb04242c74264349"/>
+    <p:sldLayoutId xmlns:r="http://schemas.openxmlformats.org/officeDocument/2006/relationships" id="2147483649" r:id="Ra4973b3aa0a54219"/>
   </p:sldLayoutIdLst>
   <p:txStyles>
     <p:titleStyle>
@@ -1345,7 +1345,7 @@
           <p:cNvPr id="5" name="">
             <a:extLst xmlns:a="http://schemas.openxmlformats.org/drawingml/2006/main">
               <a:ext uri="{FF2B5EF4-FFF2-40B4-BE49-F238E27FC236}">
-                <a16:creationId xmlns:a16="http://schemas.microsoft.com/office/drawing/2014/main" id="{6BAEBA6C-99B7-48FD-A947-52CDF48063DB}"/>
+                <a16:creationId xmlns:a16="http://schemas.microsoft.com/office/drawing/2014/main" id="{97609D6E-22BF-4FB5-9257-FB1AAA5A1816}"/>
               </a:ext>
             </a:extLst>
           </p:cNvPr>
@@ -1402,7 +1402,7 @@
           <p:cNvPr id="2" name="">
             <a:extLst xmlns:a="http://schemas.openxmlformats.org/drawingml/2006/main">
               <a:ext uri="{FF2B5EF4-FFF2-40B4-BE49-F238E27FC236}">
-                <a16:creationId xmlns:a16="http://schemas.microsoft.com/office/drawing/2014/main" id="{FB4D7D17-2F10-4DF3-ABDC-7C69DE44AE97}"/>
+                <a16:creationId xmlns:a16="http://schemas.microsoft.com/office/drawing/2014/main" id="{263126D0-97AE-4B17-9566-9CA0A2912A9C}"/>
               </a:ext>
             </a:extLst>
           </p:cNvPr>
@@ -1459,7 +1459,7 @@
           <p:cNvPr id="3" name="">
             <a:extLst xmlns:a="http://schemas.openxmlformats.org/drawingml/2006/main">
               <a:ext uri="{FF2B5EF4-FFF2-40B4-BE49-F238E27FC236}">
-                <a16:creationId xmlns:a16="http://schemas.microsoft.com/office/drawing/2014/main" id="{DCD3FEB7-7D04-44C9-938F-36315DABA08A}"/>
+                <a16:creationId xmlns:a16="http://schemas.microsoft.com/office/drawing/2014/main" id="{100B9CF2-EC9D-40A7-86B7-9CF04222F7F5}"/>
               </a:ext>
             </a:extLst>
           </p:cNvPr>
@@ -1516,7 +1516,7 @@
           <p:cNvPr id="4" name="">
             <a:extLst xmlns:a="http://schemas.openxmlformats.org/drawingml/2006/main">
               <a:ext uri="{FF2B5EF4-FFF2-40B4-BE49-F238E27FC236}">
-                <a16:creationId xmlns:a16="http://schemas.microsoft.com/office/drawing/2014/main" id="{6FD5F2C0-1EA5-4AF6-B0A1-E334912A8979}"/>
+                <a16:creationId xmlns:a16="http://schemas.microsoft.com/office/drawing/2014/main" id="{889190AA-A87D-4B69-9D10-1A913E4CAF43}"/>
               </a:ext>
             </a:extLst>
           </p:cNvPr>
@@ -1571,7 +1571,7 @@
     </p:spTree>
     <p:extLst>
       <p:ext uri="{BB962C8B-B14F-4D97-AF65-F5344CB8AC3E}">
-        <p14:creationId xmlns:p14="http://schemas.microsoft.com/office/powerpoint/2010/main" val="55745451"/>
+        <p14:creationId xmlns:p14="http://schemas.microsoft.com/office/powerpoint/2010/main" val="1047495076"/>
       </p:ext>
     </p:extLst>
   </p:cSld>
@@ -1602,7 +1602,7 @@
           <p:cNvPr id="5" name="">
             <a:extLst xmlns:a="http://schemas.openxmlformats.org/drawingml/2006/main">
               <a:ext uri="{FF2B5EF4-FFF2-40B4-BE49-F238E27FC236}">
-                <a16:creationId xmlns:a16="http://schemas.microsoft.com/office/drawing/2014/main" id="{36CAAE7D-081C-4C94-B0B0-A6D39FB1753A}"/>
+                <a16:creationId xmlns:a16="http://schemas.microsoft.com/office/drawing/2014/main" id="{D317C52D-1ED1-4F8C-8383-A7BC3B999F71}"/>
               </a:ext>
             </a:extLst>
           </p:cNvPr>
@@ -1659,7 +1659,7 @@
           <p:cNvPr id="2" name="">
             <a:extLst xmlns:a="http://schemas.openxmlformats.org/drawingml/2006/main">
               <a:ext uri="{FF2B5EF4-FFF2-40B4-BE49-F238E27FC236}">
-                <a16:creationId xmlns:a16="http://schemas.microsoft.com/office/drawing/2014/main" id="{4752A64C-0F39-4A41-982E-381D3E2D3EB2}"/>
+                <a16:creationId xmlns:a16="http://schemas.microsoft.com/office/drawing/2014/main" id="{091A783E-7A07-42AF-B2E9-09F113248D0E}"/>
               </a:ext>
             </a:extLst>
           </p:cNvPr>
@@ -1706,7 +1706,7 @@
                 <a:ea typeface="PingFang TC"/>
                 <a:cs typeface="PingFang TC"/>
               </a:rPr>
-              <a:t>揮手，翻到下一頁</a:t>
+              <a:t>比讚，翻到下一頁</a:t>
             </a:r>
           </a:p>
         </p:txBody>
@@ -1716,7 +1716,7 @@
           <p:cNvPr id="3" name="">
             <a:extLst xmlns:a="http://schemas.openxmlformats.org/drawingml/2006/main">
               <a:ext uri="{FF2B5EF4-FFF2-40B4-BE49-F238E27FC236}">
-                <a16:creationId xmlns:a16="http://schemas.microsoft.com/office/drawing/2014/main" id="{A6916A4D-1521-4177-B8E2-B2FAA1DA956F}"/>
+                <a16:creationId xmlns:a16="http://schemas.microsoft.com/office/drawing/2014/main" id="{70B4820A-55BB-42C2-A710-C41E26637BA3}"/>
               </a:ext>
             </a:extLst>
           </p:cNvPr>
@@ -1763,7 +1763,7 @@
                 <a:ea typeface="PingFang TC"/>
                 <a:cs typeface="PingFang TC"/>
               </a:rPr>
-              <a:t>張開手掌，向右揮。</a:t>
+              <a:t>拇指朝上下一頁；朝下上一頁。</a:t>
             </a:r>
           </a:p>
         </p:txBody>
@@ -1773,7 +1773,7 @@
           <p:cNvPr id="4" name="">
             <a:extLst xmlns:a="http://schemas.openxmlformats.org/drawingml/2006/main">
               <a:ext uri="{FF2B5EF4-FFF2-40B4-BE49-F238E27FC236}">
-                <a16:creationId xmlns:a16="http://schemas.microsoft.com/office/drawing/2014/main" id="{6D463F8A-C7D9-4937-A56A-C10A8FD1347A}"/>
+                <a16:creationId xmlns:a16="http://schemas.microsoft.com/office/drawing/2014/main" id="{88A249C7-853D-409F-9108-6D52855B0044}"/>
               </a:ext>
             </a:extLst>
           </p:cNvPr>
@@ -1820,7 +1820,7 @@
                 <a:ea typeface="PingFang TC"/>
                 <a:cs typeface="PingFang TC"/>
               </a:rPr>
-              <a:t>向左揮可以回到上一頁。</a:t>
+              <a:t>持續擺著只翻一頁；放鬆手，再比一次。</a:t>
             </a:r>
           </a:p>
         </p:txBody>
@@ -1828,7 +1828,7 @@
     </p:spTree>
     <p:extLst>
       <p:ext uri="{BB962C8B-B14F-4D97-AF65-F5344CB8AC3E}">
-        <p14:creationId xmlns:p14="http://schemas.microsoft.com/office/powerpoint/2010/main" val="1594984722"/>
+        <p14:creationId xmlns:p14="http://schemas.microsoft.com/office/powerpoint/2010/main" val="767153368"/>
       </p:ext>
     </p:extLst>
   </p:cSld>
@@ -1859,7 +1859,7 @@
           <p:cNvPr id="5" name="">
             <a:extLst xmlns:a="http://schemas.openxmlformats.org/drawingml/2006/main">
               <a:ext uri="{FF2B5EF4-FFF2-40B4-BE49-F238E27FC236}">
-                <a16:creationId xmlns:a16="http://schemas.microsoft.com/office/drawing/2014/main" id="{85F3C940-C771-45A8-AF1E-F8E263F8FBA0}"/>
+                <a16:creationId xmlns:a16="http://schemas.microsoft.com/office/drawing/2014/main" id="{C41B52AA-B0A6-4A01-99ED-291448479353}"/>
               </a:ext>
             </a:extLst>
           </p:cNvPr>
@@ -1916,7 +1916,7 @@
           <p:cNvPr id="2" name="">
             <a:extLst xmlns:a="http://schemas.openxmlformats.org/drawingml/2006/main">
               <a:ext uri="{FF2B5EF4-FFF2-40B4-BE49-F238E27FC236}">
-                <a16:creationId xmlns:a16="http://schemas.microsoft.com/office/drawing/2014/main" id="{493CBEF8-E75C-433B-827B-4AF118D9F051}"/>
+                <a16:creationId xmlns:a16="http://schemas.microsoft.com/office/drawing/2014/main" id="{56337DB8-C2B6-4E7E-B9D9-09BAFFA1B036}"/>
               </a:ext>
             </a:extLst>
           </p:cNvPr>
@@ -1973,7 +1973,7 @@
           <p:cNvPr id="3" name="">
             <a:extLst xmlns:a="http://schemas.openxmlformats.org/drawingml/2006/main">
               <a:ext uri="{FF2B5EF4-FFF2-40B4-BE49-F238E27FC236}">
-                <a16:creationId xmlns:a16="http://schemas.microsoft.com/office/drawing/2014/main" id="{5A706262-C030-47CA-9890-897D8D770FC0}"/>
+                <a16:creationId xmlns:a16="http://schemas.microsoft.com/office/drawing/2014/main" id="{5595C3E0-8182-4249-9334-C3737A4974F8}"/>
               </a:ext>
             </a:extLst>
           </p:cNvPr>
@@ -2030,7 +2030,7 @@
           <p:cNvPr id="4" name="">
             <a:extLst xmlns:a="http://schemas.openxmlformats.org/drawingml/2006/main">
               <a:ext uri="{FF2B5EF4-FFF2-40B4-BE49-F238E27FC236}">
-                <a16:creationId xmlns:a16="http://schemas.microsoft.com/office/drawing/2014/main" id="{9B0B50A8-193D-4C1D-AD32-7DE9174EFB13}"/>
+                <a16:creationId xmlns:a16="http://schemas.microsoft.com/office/drawing/2014/main" id="{5911D93E-66F4-45C6-8516-D504D0B4AA44}"/>
               </a:ext>
             </a:extLst>
           </p:cNvPr>
@@ -2085,7 +2085,7 @@
     </p:spTree>
     <p:extLst>
       <p:ext uri="{BB962C8B-B14F-4D97-AF65-F5344CB8AC3E}">
-        <p14:creationId xmlns:p14="http://schemas.microsoft.com/office/powerpoint/2010/main" val="1304353827"/>
+        <p14:creationId xmlns:p14="http://schemas.microsoft.com/office/powerpoint/2010/main" val="831240004"/>
       </p:ext>
     </p:extLst>
   </p:cSld>
@@ -2116,7 +2116,7 @@
           <p:cNvPr id="5" name="">
             <a:extLst xmlns:a="http://schemas.openxmlformats.org/drawingml/2006/main">
               <a:ext uri="{FF2B5EF4-FFF2-40B4-BE49-F238E27FC236}">
-                <a16:creationId xmlns:a16="http://schemas.microsoft.com/office/drawing/2014/main" id="{27161CBD-6D87-48F0-827B-B6B6FA620E78}"/>
+                <a16:creationId xmlns:a16="http://schemas.microsoft.com/office/drawing/2014/main" id="{214F3A28-400F-4FC8-A713-C1217CF154D3}"/>
               </a:ext>
             </a:extLst>
           </p:cNvPr>
@@ -2173,7 +2173,7 @@
           <p:cNvPr id="2" name="">
             <a:extLst xmlns:a="http://schemas.openxmlformats.org/drawingml/2006/main">
               <a:ext uri="{FF2B5EF4-FFF2-40B4-BE49-F238E27FC236}">
-                <a16:creationId xmlns:a16="http://schemas.microsoft.com/office/drawing/2014/main" id="{1A481B76-167D-40CC-AC34-5DDD843F1787}"/>
+                <a16:creationId xmlns:a16="http://schemas.microsoft.com/office/drawing/2014/main" id="{C9D1BF4B-621E-4D04-9DD8-A9DDC38B232B}"/>
               </a:ext>
             </a:extLst>
           </p:cNvPr>
@@ -2230,7 +2230,7 @@
           <p:cNvPr id="3" name="">
             <a:extLst xmlns:a="http://schemas.openxmlformats.org/drawingml/2006/main">
               <a:ext uri="{FF2B5EF4-FFF2-40B4-BE49-F238E27FC236}">
-                <a16:creationId xmlns:a16="http://schemas.microsoft.com/office/drawing/2014/main" id="{675C2EA1-AAC7-4094-B1A0-7268A82E7A2D}"/>
+                <a16:creationId xmlns:a16="http://schemas.microsoft.com/office/drawing/2014/main" id="{E02A0593-724D-4EB5-AB36-DFC031F0FF51}"/>
               </a:ext>
             </a:extLst>
           </p:cNvPr>
@@ -2277,7 +2277,7 @@
                 <a:ea typeface="PingFang TC"/>
                 <a:cs typeface="PingFang TC"/>
               </a:rPr>
-              <a:t>「簡報，上一頁」</a:t>
+              <a:t>「上一頁」</a:t>
             </a:r>
           </a:p>
         </p:txBody>
@@ -2287,7 +2287,7 @@
           <p:cNvPr id="4" name="">
             <a:extLst xmlns:a="http://schemas.openxmlformats.org/drawingml/2006/main">
               <a:ext uri="{FF2B5EF4-FFF2-40B4-BE49-F238E27FC236}">
-                <a16:creationId xmlns:a16="http://schemas.microsoft.com/office/drawing/2014/main" id="{9A40BD96-8228-4D17-8592-4670B3E51824}"/>
+                <a16:creationId xmlns:a16="http://schemas.microsoft.com/office/drawing/2014/main" id="{2275B73B-8B32-48B0-A375-3D61A104F897}"/>
               </a:ext>
             </a:extLst>
           </p:cNvPr>
@@ -2342,7 +2342,7 @@
     </p:spTree>
     <p:extLst>
       <p:ext uri="{BB962C8B-B14F-4D97-AF65-F5344CB8AC3E}">
-        <p14:creationId xmlns:p14="http://schemas.microsoft.com/office/powerpoint/2010/main" val="472845340"/>
+        <p14:creationId xmlns:p14="http://schemas.microsoft.com/office/powerpoint/2010/main" val="844325468"/>
       </p:ext>
     </p:extLst>
   </p:cSld>
@@ -2373,7 +2373,7 @@
           <p:cNvPr id="5" name="">
             <a:extLst xmlns:a="http://schemas.openxmlformats.org/drawingml/2006/main">
               <a:ext uri="{FF2B5EF4-FFF2-40B4-BE49-F238E27FC236}">
-                <a16:creationId xmlns:a16="http://schemas.microsoft.com/office/drawing/2014/main" id="{0FA1F6B1-D42C-4D5B-AF2B-95219CD5E2F0}"/>
+                <a16:creationId xmlns:a16="http://schemas.microsoft.com/office/drawing/2014/main" id="{9993DECD-6E73-4D6A-9C5E-53E89EDDC435}"/>
               </a:ext>
             </a:extLst>
           </p:cNvPr>
@@ -2430,7 +2430,7 @@
           <p:cNvPr id="2" name="">
             <a:extLst xmlns:a="http://schemas.openxmlformats.org/drawingml/2006/main">
               <a:ext uri="{FF2B5EF4-FFF2-40B4-BE49-F238E27FC236}">
-                <a16:creationId xmlns:a16="http://schemas.microsoft.com/office/drawing/2014/main" id="{D62CFE10-0C72-4101-A050-73A6D8C78181}"/>
+                <a16:creationId xmlns:a16="http://schemas.microsoft.com/office/drawing/2014/main" id="{8A8EC87E-95DC-4E84-A0FA-60E6EA1246EA}"/>
               </a:ext>
             </a:extLst>
           </p:cNvPr>
@@ -2487,7 +2487,7 @@
           <p:cNvPr id="3" name="">
             <a:extLst xmlns:a="http://schemas.openxmlformats.org/drawingml/2006/main">
               <a:ext uri="{FF2B5EF4-FFF2-40B4-BE49-F238E27FC236}">
-                <a16:creationId xmlns:a16="http://schemas.microsoft.com/office/drawing/2014/main" id="{E52945AF-8A25-4D96-BBF0-EBFCDF614866}"/>
+                <a16:creationId xmlns:a16="http://schemas.microsoft.com/office/drawing/2014/main" id="{103936B9-BB6A-485F-89D2-00D5E93A69F9}"/>
               </a:ext>
             </a:extLst>
           </p:cNvPr>
@@ -2544,7 +2544,7 @@
           <p:cNvPr id="4" name="">
             <a:extLst xmlns:a="http://schemas.openxmlformats.org/drawingml/2006/main">
               <a:ext uri="{FF2B5EF4-FFF2-40B4-BE49-F238E27FC236}">
-                <a16:creationId xmlns:a16="http://schemas.microsoft.com/office/drawing/2014/main" id="{66F046DC-6148-4CA8-86CA-A31B3B21845B}"/>
+                <a16:creationId xmlns:a16="http://schemas.microsoft.com/office/drawing/2014/main" id="{1AE735C5-5A0C-436D-B6AD-E46B94C521BF}"/>
               </a:ext>
             </a:extLst>
           </p:cNvPr>
@@ -2599,7 +2599,7 @@
     </p:spTree>
     <p:extLst>
       <p:ext uri="{BB962C8B-B14F-4D97-AF65-F5344CB8AC3E}">
-        <p14:creationId xmlns:p14="http://schemas.microsoft.com/office/powerpoint/2010/main" val="728077813"/>
+        <p14:creationId xmlns:p14="http://schemas.microsoft.com/office/powerpoint/2010/main" val="1290191517"/>
       </p:ext>
     </p:extLst>
   </p:cSld>

</xml_diff>